<commit_message>
chore: freeze final competition consistency
</commit_message>
<xml_diff>
--- a/submission/LabOps-Guard-GOAI-复赛方案-v1.0-rc1.pptx
+++ b/submission/LabOps-Guard-GOAI-复赛方案-v1.0-rc1.pptx
@@ -2,31 +2,31 @@
 <file path=ppt/presentation.xml><?xml version="1.0" encoding="utf-8"?>
 <p:presentation xmlns:p="http://schemas.openxmlformats.org/presentationml/2006/main">
   <p:sldMasterIdLst>
-    <p:sldMasterId xmlns:r="http://schemas.openxmlformats.org/officeDocument/2006/relationships" id="2147483648" r:id="R97b450df1eba4184"/>
-    <p:sldMasterId xmlns:r="http://schemas.openxmlformats.org/officeDocument/2006/relationships" id="2147483650" r:id="Rb942070838f645b3"/>
+    <p:sldMasterId xmlns:r="http://schemas.openxmlformats.org/officeDocument/2006/relationships" id="2147483648" r:id="Rfbe7a2d88fc94aa8"/>
+    <p:sldMasterId xmlns:r="http://schemas.openxmlformats.org/officeDocument/2006/relationships" id="2147483650" r:id="R738311b2a74b4b23"/>
   </p:sldMasterIdLst>
   <p:notesMasterIdLst>
-    <p:notesMasterId xmlns:r="http://schemas.openxmlformats.org/officeDocument/2006/relationships" r:id="R7a3bc38d5bff414e"/>
+    <p:notesMasterId xmlns:r="http://schemas.openxmlformats.org/officeDocument/2006/relationships" r:id="Rbd5f1a05a7404670"/>
   </p:notesMasterIdLst>
   <p:sldIdLst>
-    <p:sldId xmlns:r="http://schemas.openxmlformats.org/officeDocument/2006/relationships" id="256" r:id="R961fc2b1a82e454c"/>
-    <p:sldId xmlns:r="http://schemas.openxmlformats.org/officeDocument/2006/relationships" id="257" r:id="Rfa97ea75626245d8"/>
-    <p:sldId xmlns:r="http://schemas.openxmlformats.org/officeDocument/2006/relationships" id="258" r:id="Rf97152a425cf45bb"/>
-    <p:sldId xmlns:r="http://schemas.openxmlformats.org/officeDocument/2006/relationships" id="259" r:id="R19ca09f12b044772"/>
-    <p:sldId xmlns:r="http://schemas.openxmlformats.org/officeDocument/2006/relationships" id="260" r:id="Re8e2eea7277b41f8"/>
-    <p:sldId xmlns:r="http://schemas.openxmlformats.org/officeDocument/2006/relationships" id="261" r:id="R88df56ec756b4f0f"/>
-    <p:sldId xmlns:r="http://schemas.openxmlformats.org/officeDocument/2006/relationships" id="262" r:id="Rf9b5381d54b34d26"/>
-    <p:sldId xmlns:r="http://schemas.openxmlformats.org/officeDocument/2006/relationships" id="263" r:id="R4b3b2c4bea98430b"/>
-    <p:sldId xmlns:r="http://schemas.openxmlformats.org/officeDocument/2006/relationships" id="264" r:id="Re5ddaae0820941dd"/>
-    <p:sldId xmlns:r="http://schemas.openxmlformats.org/officeDocument/2006/relationships" id="265" r:id="R7684aee050e24cc6"/>
-    <p:sldId xmlns:r="http://schemas.openxmlformats.org/officeDocument/2006/relationships" id="266" r:id="Rb0fd453c18924875"/>
-    <p:sldId xmlns:r="http://schemas.openxmlformats.org/officeDocument/2006/relationships" id="267" r:id="Ra9e0d26c5c2145b3"/>
-    <p:sldId xmlns:r="http://schemas.openxmlformats.org/officeDocument/2006/relationships" id="268" r:id="R4b98b51ea0c84704"/>
-    <p:sldId xmlns:r="http://schemas.openxmlformats.org/officeDocument/2006/relationships" id="269" r:id="R9a88c76e0fbd495d"/>
-    <p:sldId xmlns:r="http://schemas.openxmlformats.org/officeDocument/2006/relationships" id="270" r:id="R42b8a988f4c444eb"/>
-    <p:sldId xmlns:r="http://schemas.openxmlformats.org/officeDocument/2006/relationships" id="271" r:id="R89618ab492894832"/>
-    <p:sldId xmlns:r="http://schemas.openxmlformats.org/officeDocument/2006/relationships" id="272" r:id="R6f468bbf61e14594"/>
-    <p:sldId xmlns:r="http://schemas.openxmlformats.org/officeDocument/2006/relationships" id="273" r:id="Rbe8fad7fc61c49a3"/>
+    <p:sldId xmlns:r="http://schemas.openxmlformats.org/officeDocument/2006/relationships" id="256" r:id="R9dbfea4a3616432e"/>
+    <p:sldId xmlns:r="http://schemas.openxmlformats.org/officeDocument/2006/relationships" id="257" r:id="R5a51a71141b04aff"/>
+    <p:sldId xmlns:r="http://schemas.openxmlformats.org/officeDocument/2006/relationships" id="258" r:id="R1642428288a7471c"/>
+    <p:sldId xmlns:r="http://schemas.openxmlformats.org/officeDocument/2006/relationships" id="259" r:id="Rbb68735aad624955"/>
+    <p:sldId xmlns:r="http://schemas.openxmlformats.org/officeDocument/2006/relationships" id="260" r:id="R353d58ebace546ce"/>
+    <p:sldId xmlns:r="http://schemas.openxmlformats.org/officeDocument/2006/relationships" id="261" r:id="Rb08bc56a2c8e429b"/>
+    <p:sldId xmlns:r="http://schemas.openxmlformats.org/officeDocument/2006/relationships" id="262" r:id="Refc2eaf75ce74679"/>
+    <p:sldId xmlns:r="http://schemas.openxmlformats.org/officeDocument/2006/relationships" id="263" r:id="R5e1bb1a71e2741c2"/>
+    <p:sldId xmlns:r="http://schemas.openxmlformats.org/officeDocument/2006/relationships" id="264" r:id="R91c6b7e251024dba"/>
+    <p:sldId xmlns:r="http://schemas.openxmlformats.org/officeDocument/2006/relationships" id="265" r:id="R42448e1f71c04bbd"/>
+    <p:sldId xmlns:r="http://schemas.openxmlformats.org/officeDocument/2006/relationships" id="266" r:id="Rb340bbf551554c5d"/>
+    <p:sldId xmlns:r="http://schemas.openxmlformats.org/officeDocument/2006/relationships" id="267" r:id="Rbe150bde4d56419e"/>
+    <p:sldId xmlns:r="http://schemas.openxmlformats.org/officeDocument/2006/relationships" id="268" r:id="Red9209395d5f40ef"/>
+    <p:sldId xmlns:r="http://schemas.openxmlformats.org/officeDocument/2006/relationships" id="269" r:id="Rcb92f37e41794505"/>
+    <p:sldId xmlns:r="http://schemas.openxmlformats.org/officeDocument/2006/relationships" id="270" r:id="Rdfc5e008e06b49c6"/>
+    <p:sldId xmlns:r="http://schemas.openxmlformats.org/officeDocument/2006/relationships" id="271" r:id="Ra2bdc0b22069439a"/>
+    <p:sldId xmlns:r="http://schemas.openxmlformats.org/officeDocument/2006/relationships" id="272" r:id="Raf4fb2145a294fce"/>
+    <p:sldId xmlns:r="http://schemas.openxmlformats.org/officeDocument/2006/relationships" id="273" r:id="R3b331ab111214a28"/>
   </p:sldIdLst>
   <p:sldSz cx="12192000" cy="6858000"/>
   <p:notesSz cx="6858000" cy="9144000"/>
@@ -1873,7 +1873,7 @@
   </p:cSld>
   <p:clrMap bg1="lt1" tx1="dk1" bg2="lt2" tx2="dk2" accent1="accent1" accent2="accent2" accent3="accent3" accent4="accent4" accent5="accent5" accent6="accent6" hlink="hlink" folHlink="folHlink"/>
   <p:sldLayoutIdLst>
-    <p:sldLayoutId xmlns:r="http://schemas.openxmlformats.org/officeDocument/2006/relationships" id="2147483649" r:id="R04615e321fde468b"/>
+    <p:sldLayoutId xmlns:r="http://schemas.openxmlformats.org/officeDocument/2006/relationships" id="2147483649" r:id="Rec4a10f54c5c4939"/>
   </p:sldLayoutIdLst>
   <p:hf sldNum="0" hdr="0" ftr="0" dt="0"/>
   <p:txStyles>
@@ -2156,7 +2156,7 @@
   </p:cSld>
   <p:clrMap bg1="lt1" tx1="dk1" bg2="lt2" tx2="dk2" accent1="accent1" accent2="accent2" accent3="accent3" accent4="accent4" accent5="accent5" accent6="accent6" hlink="hlink" folHlink="folHlink"/>
   <p:sldLayoutIdLst>
-    <p:sldLayoutId xmlns:r="http://schemas.openxmlformats.org/officeDocument/2006/relationships" id="2147483651" r:id="R25898178d16f4041"/>
+    <p:sldLayoutId xmlns:r="http://schemas.openxmlformats.org/officeDocument/2006/relationships" id="2147483651" r:id="R69b61ae0f13249fa"/>
   </p:sldLayoutIdLst>
   <p:hf sldNum="0" hdr="0" ftr="0" dt="0"/>
   <p:txStyles>
@@ -3142,7 +3142,7 @@
                 <a:ea typeface="微软雅黑"/>
                 <a:cs typeface="微软雅黑"/>
               </a:rPr>
-              <a:t>Trustworthy Agent Execution &amp; Governance Infrastructure</a:t>
+              <a:t>Trust Infrastructure for Production Agent Systems</a:t>
             </a:r>
             <a:endParaRPr sz="1500" b="1" kern="0" spc="200">
               <a:solidFill>
@@ -6632,7 +6632,7 @@
           <p:nvPr/>
         </p:nvPicPr>
         <p:blipFill>
-          <a:blip xmlns:r="http://schemas.openxmlformats.org/officeDocument/2006/relationships" xmlns:a="http://schemas.openxmlformats.org/drawingml/2006/main" r:embed="Rf59e215b6e8d4c94"/>
+          <a:blip xmlns:r="http://schemas.openxmlformats.org/officeDocument/2006/relationships" xmlns:a="http://schemas.openxmlformats.org/drawingml/2006/main" r:embed="R76c0837e7ef64a79"/>
           <a:stretch xmlns:a="http://schemas.openxmlformats.org/drawingml/2006/main"/>
         </p:blipFill>
         <p:spPr>
@@ -7664,7 +7664,7 @@
           <p:nvPr/>
         </p:nvPicPr>
         <p:blipFill>
-          <a:blip xmlns:r="http://schemas.openxmlformats.org/officeDocument/2006/relationships" xmlns:a="http://schemas.openxmlformats.org/drawingml/2006/main" r:embed="Ra94dfecfcda8471c"/>
+          <a:blip xmlns:r="http://schemas.openxmlformats.org/officeDocument/2006/relationships" xmlns:a="http://schemas.openxmlformats.org/drawingml/2006/main" r:embed="R64e0e5845e9a4de8"/>
           <a:stretch xmlns:a="http://schemas.openxmlformats.org/drawingml/2006/main"/>
         </p:blipFill>
         <p:spPr>
@@ -10305,7 +10305,7 @@
           <p:nvPr/>
         </p:nvPicPr>
         <p:blipFill>
-          <a:blip xmlns:r="http://schemas.openxmlformats.org/officeDocument/2006/relationships" xmlns:a="http://schemas.openxmlformats.org/drawingml/2006/main" r:embed="R3308d614823642f2"/>
+          <a:blip xmlns:r="http://schemas.openxmlformats.org/officeDocument/2006/relationships" xmlns:a="http://schemas.openxmlformats.org/drawingml/2006/main" r:embed="R0c0725e84dde4644"/>
           <a:stretch xmlns:a="http://schemas.openxmlformats.org/drawingml/2006/main"/>
         </p:blipFill>
         <p:spPr>
@@ -10327,7 +10327,7 @@
           <p:nvPr/>
         </p:nvPicPr>
         <p:blipFill>
-          <a:blip xmlns:r="http://schemas.openxmlformats.org/officeDocument/2006/relationships" xmlns:a="http://schemas.openxmlformats.org/drawingml/2006/main" r:embed="R7b53332ebe62491d"/>
+          <a:blip xmlns:r="http://schemas.openxmlformats.org/officeDocument/2006/relationships" xmlns:a="http://schemas.openxmlformats.org/drawingml/2006/main" r:embed="Rde5dc54bbf054dfb"/>
           <a:stretch xmlns:a="http://schemas.openxmlformats.org/drawingml/2006/main"/>
         </p:blipFill>
         <p:spPr>
@@ -11656,16 +11656,7 @@
               </a:rPr>
               <a:t>GitHub: github.com/JAKIIC/LabOps-Guard</a:t>
             </a:r>
-            <a:br>
-              <a:rPr sz="1575" b="1">
-                <a:solidFill>
-                  <a:srgbClr val="1D2342"/>
-                </a:solidFill>
-                <a:latin typeface="微软雅黑"/>
-                <a:ea typeface="微软雅黑"/>
-                <a:cs typeface="微软雅黑"/>
-              </a:rPr>
-            </a:br>
+            <a:br/>
             <a:r>
               <a:rPr sz="1575" b="1">
                 <a:solidFill>
@@ -11689,7 +11680,7 @@
           <p:nvPr/>
         </p:nvPicPr>
         <p:blipFill>
-          <a:blip xmlns:r="http://schemas.openxmlformats.org/officeDocument/2006/relationships" xmlns:a="http://schemas.openxmlformats.org/drawingml/2006/main" r:embed="R05278a1482fb46ac"/>
+          <a:blip xmlns:r="http://schemas.openxmlformats.org/officeDocument/2006/relationships" xmlns:a="http://schemas.openxmlformats.org/drawingml/2006/main" r:embed="R306bac6c3c5e4ca1"/>
           <a:stretch xmlns:a="http://schemas.openxmlformats.org/drawingml/2006/main"/>
         </p:blipFill>
         <p:spPr>

</xml_diff>

<commit_message>
fix: resolve final consistency review findings
</commit_message>
<xml_diff>
--- a/submission/LabOps-Guard-GOAI-复赛方案-v1.0-rc1.pptx
+++ b/submission/LabOps-Guard-GOAI-复赛方案-v1.0-rc1.pptx
@@ -2,31 +2,31 @@
 <file path=ppt/presentation.xml><?xml version="1.0" encoding="utf-8"?>
 <p:presentation xmlns:p="http://schemas.openxmlformats.org/presentationml/2006/main">
   <p:sldMasterIdLst>
-    <p:sldMasterId xmlns:r="http://schemas.openxmlformats.org/officeDocument/2006/relationships" id="2147483648" r:id="Rfbe7a2d88fc94aa8"/>
-    <p:sldMasterId xmlns:r="http://schemas.openxmlformats.org/officeDocument/2006/relationships" id="2147483650" r:id="R738311b2a74b4b23"/>
+    <p:sldMasterId xmlns:r="http://schemas.openxmlformats.org/officeDocument/2006/relationships" id="2147483648" r:id="R079439bb32594c77"/>
+    <p:sldMasterId xmlns:r="http://schemas.openxmlformats.org/officeDocument/2006/relationships" id="2147483650" r:id="Re57d578e5f354db2"/>
   </p:sldMasterIdLst>
   <p:notesMasterIdLst>
-    <p:notesMasterId xmlns:r="http://schemas.openxmlformats.org/officeDocument/2006/relationships" r:id="Rbd5f1a05a7404670"/>
+    <p:notesMasterId xmlns:r="http://schemas.openxmlformats.org/officeDocument/2006/relationships" r:id="Rd49612d7b8be41bd"/>
   </p:notesMasterIdLst>
   <p:sldIdLst>
-    <p:sldId xmlns:r="http://schemas.openxmlformats.org/officeDocument/2006/relationships" id="256" r:id="R9dbfea4a3616432e"/>
-    <p:sldId xmlns:r="http://schemas.openxmlformats.org/officeDocument/2006/relationships" id="257" r:id="R5a51a71141b04aff"/>
-    <p:sldId xmlns:r="http://schemas.openxmlformats.org/officeDocument/2006/relationships" id="258" r:id="R1642428288a7471c"/>
-    <p:sldId xmlns:r="http://schemas.openxmlformats.org/officeDocument/2006/relationships" id="259" r:id="Rbb68735aad624955"/>
-    <p:sldId xmlns:r="http://schemas.openxmlformats.org/officeDocument/2006/relationships" id="260" r:id="R353d58ebace546ce"/>
-    <p:sldId xmlns:r="http://schemas.openxmlformats.org/officeDocument/2006/relationships" id="261" r:id="Rb08bc56a2c8e429b"/>
-    <p:sldId xmlns:r="http://schemas.openxmlformats.org/officeDocument/2006/relationships" id="262" r:id="Refc2eaf75ce74679"/>
-    <p:sldId xmlns:r="http://schemas.openxmlformats.org/officeDocument/2006/relationships" id="263" r:id="R5e1bb1a71e2741c2"/>
-    <p:sldId xmlns:r="http://schemas.openxmlformats.org/officeDocument/2006/relationships" id="264" r:id="R91c6b7e251024dba"/>
-    <p:sldId xmlns:r="http://schemas.openxmlformats.org/officeDocument/2006/relationships" id="265" r:id="R42448e1f71c04bbd"/>
-    <p:sldId xmlns:r="http://schemas.openxmlformats.org/officeDocument/2006/relationships" id="266" r:id="Rb340bbf551554c5d"/>
-    <p:sldId xmlns:r="http://schemas.openxmlformats.org/officeDocument/2006/relationships" id="267" r:id="Rbe150bde4d56419e"/>
-    <p:sldId xmlns:r="http://schemas.openxmlformats.org/officeDocument/2006/relationships" id="268" r:id="Red9209395d5f40ef"/>
-    <p:sldId xmlns:r="http://schemas.openxmlformats.org/officeDocument/2006/relationships" id="269" r:id="Rcb92f37e41794505"/>
-    <p:sldId xmlns:r="http://schemas.openxmlformats.org/officeDocument/2006/relationships" id="270" r:id="Rdfc5e008e06b49c6"/>
-    <p:sldId xmlns:r="http://schemas.openxmlformats.org/officeDocument/2006/relationships" id="271" r:id="Ra2bdc0b22069439a"/>
-    <p:sldId xmlns:r="http://schemas.openxmlformats.org/officeDocument/2006/relationships" id="272" r:id="Raf4fb2145a294fce"/>
-    <p:sldId xmlns:r="http://schemas.openxmlformats.org/officeDocument/2006/relationships" id="273" r:id="R3b331ab111214a28"/>
+    <p:sldId xmlns:r="http://schemas.openxmlformats.org/officeDocument/2006/relationships" id="256" r:id="R9ad7365767884ec2"/>
+    <p:sldId xmlns:r="http://schemas.openxmlformats.org/officeDocument/2006/relationships" id="257" r:id="R00ea209adca24a0d"/>
+    <p:sldId xmlns:r="http://schemas.openxmlformats.org/officeDocument/2006/relationships" id="258" r:id="R7e2d6742e2bc4ea9"/>
+    <p:sldId xmlns:r="http://schemas.openxmlformats.org/officeDocument/2006/relationships" id="259" r:id="R64aecc8400de4910"/>
+    <p:sldId xmlns:r="http://schemas.openxmlformats.org/officeDocument/2006/relationships" id="260" r:id="R723907d912204b60"/>
+    <p:sldId xmlns:r="http://schemas.openxmlformats.org/officeDocument/2006/relationships" id="261" r:id="R23455ef404024121"/>
+    <p:sldId xmlns:r="http://schemas.openxmlformats.org/officeDocument/2006/relationships" id="262" r:id="Ra31fb39d0a074271"/>
+    <p:sldId xmlns:r="http://schemas.openxmlformats.org/officeDocument/2006/relationships" id="263" r:id="R5d405728e78147b7"/>
+    <p:sldId xmlns:r="http://schemas.openxmlformats.org/officeDocument/2006/relationships" id="264" r:id="R791aeb6d379a4cea"/>
+    <p:sldId xmlns:r="http://schemas.openxmlformats.org/officeDocument/2006/relationships" id="265" r:id="R41763e24c0c94fed"/>
+    <p:sldId xmlns:r="http://schemas.openxmlformats.org/officeDocument/2006/relationships" id="266" r:id="Rc9e4992cdc2842ee"/>
+    <p:sldId xmlns:r="http://schemas.openxmlformats.org/officeDocument/2006/relationships" id="267" r:id="R451c0e97be7242aa"/>
+    <p:sldId xmlns:r="http://schemas.openxmlformats.org/officeDocument/2006/relationships" id="268" r:id="R07b0b3ca7bdc4697"/>
+    <p:sldId xmlns:r="http://schemas.openxmlformats.org/officeDocument/2006/relationships" id="269" r:id="R6077b8c219634a7b"/>
+    <p:sldId xmlns:r="http://schemas.openxmlformats.org/officeDocument/2006/relationships" id="270" r:id="R008d4d7086424b3c"/>
+    <p:sldId xmlns:r="http://schemas.openxmlformats.org/officeDocument/2006/relationships" id="271" r:id="R9aa6031d37b24a45"/>
+    <p:sldId xmlns:r="http://schemas.openxmlformats.org/officeDocument/2006/relationships" id="272" r:id="Rc7d0c76f04834b14"/>
+    <p:sldId xmlns:r="http://schemas.openxmlformats.org/officeDocument/2006/relationships" id="273" r:id="Rb672eacd9d6648c7"/>
   </p:sldIdLst>
   <p:sldSz cx="12192000" cy="6858000"/>
   <p:notesSz cx="6858000" cy="9144000"/>
@@ -1873,7 +1873,7 @@
   </p:cSld>
   <p:clrMap bg1="lt1" tx1="dk1" bg2="lt2" tx2="dk2" accent1="accent1" accent2="accent2" accent3="accent3" accent4="accent4" accent5="accent5" accent6="accent6" hlink="hlink" folHlink="folHlink"/>
   <p:sldLayoutIdLst>
-    <p:sldLayoutId xmlns:r="http://schemas.openxmlformats.org/officeDocument/2006/relationships" id="2147483649" r:id="Rec4a10f54c5c4939"/>
+    <p:sldLayoutId xmlns:r="http://schemas.openxmlformats.org/officeDocument/2006/relationships" id="2147483649" r:id="Rb53dc6eeea1d4cb3"/>
   </p:sldLayoutIdLst>
   <p:hf sldNum="0" hdr="0" ftr="0" dt="0"/>
   <p:txStyles>
@@ -2156,7 +2156,7 @@
   </p:cSld>
   <p:clrMap bg1="lt1" tx1="dk1" bg2="lt2" tx2="dk2" accent1="accent1" accent2="accent2" accent3="accent3" accent4="accent4" accent5="accent5" accent6="accent6" hlink="hlink" folHlink="folHlink"/>
   <p:sldLayoutIdLst>
-    <p:sldLayoutId xmlns:r="http://schemas.openxmlformats.org/officeDocument/2006/relationships" id="2147483651" r:id="R69b61ae0f13249fa"/>
+    <p:sldLayoutId xmlns:r="http://schemas.openxmlformats.org/officeDocument/2006/relationships" id="2147483651" r:id="Rf59871814ab74cab"/>
   </p:sldLayoutIdLst>
   <p:hf sldNum="0" hdr="0" ftr="0" dt="0"/>
   <p:txStyles>
@@ -5770,7 +5770,7 @@
                 <a:ea typeface="微软雅黑"/>
                 <a:cs typeface="微软雅黑"/>
               </a:rPr>
-              <a:t>固定 checkpoint、验证集、metric、模型和协议后，三次结果仍为 71.875%。</a:t>
+              <a:t>固定 checkpoint、验证集、metric、模型和协议，三次结果均为 71.875%。</a:t>
             </a:r>
             <a:endParaRPr>
               <a:latin typeface="微软雅黑"/>
@@ -6632,7 +6632,7 @@
           <p:nvPr/>
         </p:nvPicPr>
         <p:blipFill>
-          <a:blip xmlns:r="http://schemas.openxmlformats.org/officeDocument/2006/relationships" xmlns:a="http://schemas.openxmlformats.org/drawingml/2006/main" r:embed="R76c0837e7ef64a79"/>
+          <a:blip xmlns:r="http://schemas.openxmlformats.org/officeDocument/2006/relationships" xmlns:a="http://schemas.openxmlformats.org/drawingml/2006/main" r:embed="Rb3192c6609984496"/>
           <a:stretch xmlns:a="http://schemas.openxmlformats.org/drawingml/2006/main"/>
         </p:blipFill>
         <p:spPr>
@@ -7664,7 +7664,7 @@
           <p:nvPr/>
         </p:nvPicPr>
         <p:blipFill>
-          <a:blip xmlns:r="http://schemas.openxmlformats.org/officeDocument/2006/relationships" xmlns:a="http://schemas.openxmlformats.org/drawingml/2006/main" r:embed="R64e0e5845e9a4de8"/>
+          <a:blip xmlns:r="http://schemas.openxmlformats.org/officeDocument/2006/relationships" xmlns:a="http://schemas.openxmlformats.org/drawingml/2006/main" r:embed="R5f314e0e9cba4ca6"/>
           <a:stretch xmlns:a="http://schemas.openxmlformats.org/drawingml/2006/main"/>
         </p:blipFill>
         <p:spPr>
@@ -10305,7 +10305,7 @@
           <p:nvPr/>
         </p:nvPicPr>
         <p:blipFill>
-          <a:blip xmlns:r="http://schemas.openxmlformats.org/officeDocument/2006/relationships" xmlns:a="http://schemas.openxmlformats.org/drawingml/2006/main" r:embed="R0c0725e84dde4644"/>
+          <a:blip xmlns:r="http://schemas.openxmlformats.org/officeDocument/2006/relationships" xmlns:a="http://schemas.openxmlformats.org/drawingml/2006/main" r:embed="R47c1346aa6a14d28"/>
           <a:stretch xmlns:a="http://schemas.openxmlformats.org/drawingml/2006/main"/>
         </p:blipFill>
         <p:spPr>
@@ -10327,7 +10327,7 @@
           <p:nvPr/>
         </p:nvPicPr>
         <p:blipFill>
-          <a:blip xmlns:r="http://schemas.openxmlformats.org/officeDocument/2006/relationships" xmlns:a="http://schemas.openxmlformats.org/drawingml/2006/main" r:embed="Rde5dc54bbf054dfb"/>
+          <a:blip xmlns:r="http://schemas.openxmlformats.org/officeDocument/2006/relationships" xmlns:a="http://schemas.openxmlformats.org/drawingml/2006/main" r:embed="R273781f896ad4e73"/>
           <a:stretch xmlns:a="http://schemas.openxmlformats.org/drawingml/2006/main"/>
         </p:blipFill>
         <p:spPr>
@@ -11680,7 +11680,7 @@
           <p:nvPr/>
         </p:nvPicPr>
         <p:blipFill>
-          <a:blip xmlns:r="http://schemas.openxmlformats.org/officeDocument/2006/relationships" xmlns:a="http://schemas.openxmlformats.org/drawingml/2006/main" r:embed="R306bac6c3c5e4ca1"/>
+          <a:blip xmlns:r="http://schemas.openxmlformats.org/officeDocument/2006/relationships" xmlns:a="http://schemas.openxmlformats.org/drawingml/2006/main" r:embed="R8fc44e573b014023"/>
           <a:stretch xmlns:a="http://schemas.openxmlformats.org/drawingml/2006/main"/>
         </p:blipFill>
         <p:spPr>
@@ -16374,7 +16374,7 @@
                 <a:ea typeface="微软雅黑"/>
                 <a:cs typeface="微软雅黑"/>
               </a:rPr>
-              <a:t>未授权 Agent 或 Registry 损坏时 fail closed；不新增 Agent 或 Skill。</a:t>
+              <a:t>未授权 Agent 或 Registry 损坏时 fail closed；不新增 Agent/Skill。</a:t>
             </a:r>
           </a:p>
         </p:txBody>

</xml_diff>

<commit_message>
docs: align semifinal story and submission materials
</commit_message>
<xml_diff>
--- a/submission/LabOps-Guard-GOAI-复赛方案-v1.0-rc1.pptx
+++ b/submission/LabOps-Guard-GOAI-复赛方案-v1.0-rc1.pptx
@@ -2,31 +2,31 @@
 <file path=ppt/presentation.xml><?xml version="1.0" encoding="utf-8"?>
 <p:presentation xmlns:p="http://schemas.openxmlformats.org/presentationml/2006/main">
   <p:sldMasterIdLst>
-    <p:sldMasterId xmlns:r="http://schemas.openxmlformats.org/officeDocument/2006/relationships" id="2147483648" r:id="R359638d8ccc946e6"/>
-    <p:sldMasterId xmlns:r="http://schemas.openxmlformats.org/officeDocument/2006/relationships" id="2147483650" r:id="R3d5098fb0be34d06"/>
+    <p:sldMasterId xmlns:r="http://schemas.openxmlformats.org/officeDocument/2006/relationships" id="2147483648" r:id="R6aaefbe5bb1b4341"/>
+    <p:sldMasterId xmlns:r="http://schemas.openxmlformats.org/officeDocument/2006/relationships" id="2147483650" r:id="R830847ee9e404772"/>
   </p:sldMasterIdLst>
   <p:notesMasterIdLst>
-    <p:notesMasterId xmlns:r="http://schemas.openxmlformats.org/officeDocument/2006/relationships" r:id="R1b4ec6001caf43f8"/>
+    <p:notesMasterId xmlns:r="http://schemas.openxmlformats.org/officeDocument/2006/relationships" r:id="Rce7c93aeeabd4d78"/>
   </p:notesMasterIdLst>
   <p:sldIdLst>
-    <p:sldId xmlns:r="http://schemas.openxmlformats.org/officeDocument/2006/relationships" id="256" r:id="Rd4bcb63e2f9b4b2b"/>
-    <p:sldId xmlns:r="http://schemas.openxmlformats.org/officeDocument/2006/relationships" id="257" r:id="Rd6cda0383d764169"/>
-    <p:sldId xmlns:r="http://schemas.openxmlformats.org/officeDocument/2006/relationships" id="258" r:id="R7174ae3dad354244"/>
-    <p:sldId xmlns:r="http://schemas.openxmlformats.org/officeDocument/2006/relationships" id="259" r:id="Rb1276729e7604e9b"/>
-    <p:sldId xmlns:r="http://schemas.openxmlformats.org/officeDocument/2006/relationships" id="260" r:id="R0655d05ea01546ec"/>
-    <p:sldId xmlns:r="http://schemas.openxmlformats.org/officeDocument/2006/relationships" id="261" r:id="R33741d50408a46d0"/>
-    <p:sldId xmlns:r="http://schemas.openxmlformats.org/officeDocument/2006/relationships" id="262" r:id="R13ad0f242ff6440f"/>
-    <p:sldId xmlns:r="http://schemas.openxmlformats.org/officeDocument/2006/relationships" id="263" r:id="R1a4a6ff024b04228"/>
-    <p:sldId xmlns:r="http://schemas.openxmlformats.org/officeDocument/2006/relationships" id="264" r:id="Rc2dadc82dd0f4337"/>
-    <p:sldId xmlns:r="http://schemas.openxmlformats.org/officeDocument/2006/relationships" id="265" r:id="R677b2b135dfa4d79"/>
-    <p:sldId xmlns:r="http://schemas.openxmlformats.org/officeDocument/2006/relationships" id="266" r:id="R5c6ee593a3fa44f0"/>
-    <p:sldId xmlns:r="http://schemas.openxmlformats.org/officeDocument/2006/relationships" id="267" r:id="Rc2a47a40a626474d"/>
-    <p:sldId xmlns:r="http://schemas.openxmlformats.org/officeDocument/2006/relationships" id="268" r:id="R9a4fff4e0afa4781"/>
-    <p:sldId xmlns:r="http://schemas.openxmlformats.org/officeDocument/2006/relationships" id="269" r:id="Rd8aaa84b04ec404a"/>
-    <p:sldId xmlns:r="http://schemas.openxmlformats.org/officeDocument/2006/relationships" id="270" r:id="R04dda8f29f0742cf"/>
-    <p:sldId xmlns:r="http://schemas.openxmlformats.org/officeDocument/2006/relationships" id="271" r:id="Rac386cb63a024bfa"/>
-    <p:sldId xmlns:r="http://schemas.openxmlformats.org/officeDocument/2006/relationships" id="272" r:id="R36232e551bb84f07"/>
-    <p:sldId xmlns:r="http://schemas.openxmlformats.org/officeDocument/2006/relationships" id="273" r:id="R173d992d9e7d41ae"/>
+    <p:sldId xmlns:r="http://schemas.openxmlformats.org/officeDocument/2006/relationships" id="256" r:id="Rb42e70698db74d27"/>
+    <p:sldId xmlns:r="http://schemas.openxmlformats.org/officeDocument/2006/relationships" id="257" r:id="Rec87320b7d47492e"/>
+    <p:sldId xmlns:r="http://schemas.openxmlformats.org/officeDocument/2006/relationships" id="258" r:id="R09501167e352495d"/>
+    <p:sldId xmlns:r="http://schemas.openxmlformats.org/officeDocument/2006/relationships" id="259" r:id="Rbf46fd0bca074a96"/>
+    <p:sldId xmlns:r="http://schemas.openxmlformats.org/officeDocument/2006/relationships" id="260" r:id="Rb9f058ff619d45a3"/>
+    <p:sldId xmlns:r="http://schemas.openxmlformats.org/officeDocument/2006/relationships" id="261" r:id="R90304ee631d34a27"/>
+    <p:sldId xmlns:r="http://schemas.openxmlformats.org/officeDocument/2006/relationships" id="262" r:id="R6a1d08e935ad426b"/>
+    <p:sldId xmlns:r="http://schemas.openxmlformats.org/officeDocument/2006/relationships" id="263" r:id="R4cecb2347c3e41ae"/>
+    <p:sldId xmlns:r="http://schemas.openxmlformats.org/officeDocument/2006/relationships" id="264" r:id="Rb1a248d174904f61"/>
+    <p:sldId xmlns:r="http://schemas.openxmlformats.org/officeDocument/2006/relationships" id="265" r:id="R3b3fca69618444a7"/>
+    <p:sldId xmlns:r="http://schemas.openxmlformats.org/officeDocument/2006/relationships" id="266" r:id="R530dcbeb49134b14"/>
+    <p:sldId xmlns:r="http://schemas.openxmlformats.org/officeDocument/2006/relationships" id="267" r:id="R9cd20e558d054ce4"/>
+    <p:sldId xmlns:r="http://schemas.openxmlformats.org/officeDocument/2006/relationships" id="268" r:id="Rc2f796370e3f46dd"/>
+    <p:sldId xmlns:r="http://schemas.openxmlformats.org/officeDocument/2006/relationships" id="269" r:id="Rfa292f24c241426d"/>
+    <p:sldId xmlns:r="http://schemas.openxmlformats.org/officeDocument/2006/relationships" id="270" r:id="R8e063013d0c14448"/>
+    <p:sldId xmlns:r="http://schemas.openxmlformats.org/officeDocument/2006/relationships" id="271" r:id="R7bc3df798ae24f82"/>
+    <p:sldId xmlns:r="http://schemas.openxmlformats.org/officeDocument/2006/relationships" id="272" r:id="R506cb708fc534605"/>
+    <p:sldId xmlns:r="http://schemas.openxmlformats.org/officeDocument/2006/relationships" id="273" r:id="R794d114c70b24f51"/>
   </p:sldIdLst>
   <p:sldSz cx="12192000" cy="6858000"/>
   <p:notesSz cx="6858000" cy="9144000"/>
@@ -2065,7 +2065,7 @@
   </p:cSld>
   <p:clrMap bg1="lt1" tx1="dk1" bg2="lt2" tx2="dk2" accent1="accent1" accent2="accent2" accent3="accent3" accent4="accent4" accent5="accent5" accent6="accent6" hlink="hlink" folHlink="folHlink"/>
   <p:sldLayoutIdLst>
-    <p:sldLayoutId xmlns:r="http://schemas.openxmlformats.org/officeDocument/2006/relationships" id="2147483649" r:id="R522fb3dfc567408a"/>
+    <p:sldLayoutId xmlns:r="http://schemas.openxmlformats.org/officeDocument/2006/relationships" id="2147483649" r:id="R34753fee4c7d4a2b"/>
   </p:sldLayoutIdLst>
   <p:hf sldNum="0" hdr="0" ftr="0" dt="0"/>
   <p:txStyles>
@@ -2348,7 +2348,7 @@
   </p:cSld>
   <p:clrMap bg1="lt1" tx1="dk1" bg2="lt2" tx2="dk2" accent1="accent1" accent2="accent2" accent3="accent3" accent4="accent4" accent5="accent5" accent6="accent6" hlink="hlink" folHlink="folHlink"/>
   <p:sldLayoutIdLst>
-    <p:sldLayoutId xmlns:r="http://schemas.openxmlformats.org/officeDocument/2006/relationships" id="2147483651" r:id="R1bc643f8df824f87"/>
+    <p:sldLayoutId xmlns:r="http://schemas.openxmlformats.org/officeDocument/2006/relationships" id="2147483651" r:id="R97aff0d3c34546e7"/>
   </p:sldLayoutIdLst>
   <p:hf sldNum="0" hdr="0" ftr="0" dt="0"/>
   <p:txStyles>
@@ -4632,7 +4632,7 @@
           <p:nvPr/>
         </p:nvPicPr>
         <p:blipFill>
-          <a:blip xmlns:r="http://schemas.openxmlformats.org/officeDocument/2006/relationships" xmlns:a="http://schemas.openxmlformats.org/drawingml/2006/main" r:embed="Re764040ebaee470b"/>
+          <a:blip xmlns:r="http://schemas.openxmlformats.org/officeDocument/2006/relationships" xmlns:a="http://schemas.openxmlformats.org/drawingml/2006/main" r:embed="R356634331864487a"/>
           <a:srcRect xmlns:a="http://schemas.openxmlformats.org/drawingml/2006/main" l="0" t="11709" r="0" b="11709"/>
           <a:stretch xmlns:a="http://schemas.openxmlformats.org/drawingml/2006/main">
             <a:fillRect l="0" t="0" r="0" b="0"/>
@@ -6679,7 +6679,7 @@
           <p:nvPr/>
         </p:nvPicPr>
         <p:blipFill>
-          <a:blip xmlns:r="http://schemas.openxmlformats.org/officeDocument/2006/relationships" xmlns:a="http://schemas.openxmlformats.org/drawingml/2006/main" r:embed="Rd52801de8792487f"/>
+          <a:blip xmlns:r="http://schemas.openxmlformats.org/officeDocument/2006/relationships" xmlns:a="http://schemas.openxmlformats.org/drawingml/2006/main" r:embed="Rcd920ab25f8a4c1f"/>
           <a:stretch xmlns:a="http://schemas.openxmlformats.org/drawingml/2006/main"/>
         </p:blipFill>
         <p:spPr>
@@ -8829,7 +8829,7 @@
                 <a:ea typeface="微软雅黑"/>
                 <a:cs typeface="微软雅黑"/>
               </a:rPr>
-              <a:t>13 · Engineering Validation</a:t>
+              <a:t>13 · Engineering Validation &amp; Recovery</a:t>
             </a:r>
             <a:endParaRPr sz="1200"/>
           </a:p>
@@ -8875,7 +8875,7 @@
                 <a:ea typeface="微软雅黑"/>
                 <a:cs typeface="微软雅黑"/>
               </a:rPr>
-              <a:t>冻结版本的完成声明都有自动化证据</a:t>
+              <a:t>167 项测试覆盖正常闭环与异常接管</a:t>
             </a:r>
             <a:endParaRPr sz="2900"/>
           </a:p>
@@ -8917,7 +8917,7 @@
                 <a:ea typeface="微软雅黑"/>
                 <a:cs typeface="微软雅黑"/>
               </a:rPr>
-              <a:t>代码、Evidence、Public Demo、只读边界与开源合规分别验证。</a:t>
+              <a:t>Approval、Session 隔离、Recovery / Takeover 与 Skill binding 均有自动化回归。</a:t>
             </a:r>
             <a:endParaRPr>
               <a:latin typeface="微软雅黑"/>
@@ -9042,7 +9042,7 @@
                 <a:ea typeface="微软雅黑"/>
                 <a:cs typeface="微软雅黑"/>
               </a:rPr>
-              <a:t>127 tests  ·  125 passed  ·  2 optional PyTorch skipped</a:t>
+              <a:t>167 tests passed  ·  Approval / Live Session / Recovery / Skill binding</a:t>
             </a:r>
           </a:p>
         </p:txBody>
@@ -9221,7 +9221,7 @@
                 <a:ea typeface="微软雅黑"/>
                 <a:cs typeface="微软雅黑"/>
               </a:rPr>
-              <a:t>CI / Hygiene</a:t>
+              <a:t>Recovery / Takeover</a:t>
             </a:r>
           </a:p>
         </p:txBody>
@@ -9282,7 +9282,7 @@
                 <a:ea typeface="微软雅黑"/>
                 <a:cs typeface="微软雅黑"/>
               </a:rPr>
-              <a:t>Windows/Linux CI  ·  sensitive scan PASS  ·  SBOM / NOTICE / License gates</a:t>
+              <a:t>append-only attempts · retry budget · real-worker proof · human accept/resume · Auditor final</a:t>
             </a:r>
           </a:p>
         </p:txBody>
@@ -9395,7 +9395,7 @@
                 <a:ea typeface="微软雅黑"/>
                 <a:cs typeface="微软雅黑"/>
               </a:rPr>
-              <a:t>开放复用，边界同样明确</a:t>
+              <a:t>开放复用，生产边界与运维路线同样明确</a:t>
             </a:r>
             <a:endParaRPr sz="2900"/>
           </a:p>
@@ -9437,7 +9437,7 @@
                 <a:ea typeface="微软雅黑"/>
                 <a:cs typeface="微软雅黑"/>
               </a:rPr>
-              <a:t>Apache-2.0 源码、7 Skills、Schema、Evidence、CI 与 Public Demo 支持第三方复核和复用。</a:t>
+              <a:t>Apache-2.0 源码、7 Skills、Schema、Evidence、CI 与 Public Demo 支持第三方复核；生产能力分层规划。</a:t>
             </a:r>
             <a:endParaRPr>
               <a:latin typeface="微软雅黑"/>
@@ -9844,7 +9844,7 @@
                 <a:ea typeface="微软雅黑"/>
                 <a:cs typeface="微软雅黑"/>
               </a:rPr>
-              <a:t>策略身份与固定 allowlist；非 production IAM、非多租户 Runtime、无 native MCP / OTel backend。</a:t>
+              <a:t>策略身份、固定 allowlist 与文件型 observability；已支持 recovery / takeover，不宣称 HA 或多租户。</a:t>
             </a:r>
           </a:p>
         </p:txBody>
@@ -9881,7 +9881,7 @@
         </p:spPr>
         <p:txBody>
           <a:bodyPr xmlns:a="http://schemas.openxmlformats.org/drawingml/2006/main" lIns="133350" tIns="76200" rIns="133350" bIns="76200" anchor="ctr">
-            <a:normAutofit fontScale="80097"/>
+            <a:normAutofit fontScale="73447"/>
           </a:bodyPr>
           <a:lstStyle xmlns:a="http://schemas.openxmlformats.org/drawingml/2006/main"/>
           <a:p xmlns:a="http://schemas.openxmlformats.org/drawingml/2006/main">
@@ -9905,7 +9905,7 @@
                 <a:ea typeface="微软雅黑"/>
                 <a:cs typeface="微软雅黑"/>
               </a:rPr>
-              <a:t>路线：production identity + scheduling + telemetry · Runner 镜像许可证门禁关闭前不发布</a:t>
+              <a:t>路线：IAM/KMS · immutable storage · alerting · release rollback · OTel adapter · 本轮不堆叠组件</a:t>
             </a:r>
           </a:p>
         </p:txBody>
@@ -10584,14 +10584,14 @@
       </p:sp>
       <p:pic>
         <p:nvPicPr>
-          <p:cNvPr id="59" name=""/>
+          <p:cNvPr id="61" name=""/>
           <p:cNvPicPr>
             <a:picLocks xmlns:a="http://schemas.openxmlformats.org/drawingml/2006/main" noChangeAspect="1"/>
           </p:cNvPicPr>
           <p:nvPr/>
         </p:nvPicPr>
         <p:blipFill>
-          <a:blip xmlns:r="http://schemas.openxmlformats.org/officeDocument/2006/relationships" xmlns:a="http://schemas.openxmlformats.org/drawingml/2006/main" r:embed="Rb4ee4809d2b4484a"/>
+          <a:blip xmlns:r="http://schemas.openxmlformats.org/officeDocument/2006/relationships" xmlns:a="http://schemas.openxmlformats.org/drawingml/2006/main" r:embed="R593df4d159a643cf"/>
           <a:stretch xmlns:a="http://schemas.openxmlformats.org/drawingml/2006/main"/>
         </p:blipFill>
         <p:spPr>
@@ -10606,14 +10606,14 @@
       </p:pic>
       <p:pic>
         <p:nvPicPr>
-          <p:cNvPr id="60" name=""/>
+          <p:cNvPr id="62" name=""/>
           <p:cNvPicPr>
             <a:picLocks xmlns:a="http://schemas.openxmlformats.org/drawingml/2006/main" noChangeAspect="1"/>
           </p:cNvPicPr>
           <p:nvPr/>
         </p:nvPicPr>
         <p:blipFill>
-          <a:blip xmlns:r="http://schemas.openxmlformats.org/officeDocument/2006/relationships" xmlns:a="http://schemas.openxmlformats.org/drawingml/2006/main" r:embed="R6619fc11809b469b"/>
+          <a:blip xmlns:r="http://schemas.openxmlformats.org/officeDocument/2006/relationships" xmlns:a="http://schemas.openxmlformats.org/drawingml/2006/main" r:embed="R1aa701da4e6f494f"/>
           <a:stretch xmlns:a="http://schemas.openxmlformats.org/drawingml/2006/main"/>
         </p:blipFill>
         <p:spPr>
@@ -10659,6 +10659,7 @@
           <a:lstStyle xmlns:a="http://schemas.openxmlformats.org/drawingml/2006/main"/>
           <a:p xmlns:a="http://schemas.openxmlformats.org/drawingml/2006/main">
             <a:pPr algn="ctr">
+              <a:buNone/>
               <a:defRPr sz="900" b="1">
                 <a:solidFill>
                   <a:srgbClr val="475569"/>
@@ -10709,6 +10710,7 @@
           <a:lstStyle xmlns:a="http://schemas.openxmlformats.org/drawingml/2006/main"/>
           <a:p xmlns:a="http://schemas.openxmlformats.org/drawingml/2006/main">
             <a:pPr algn="ctr">
+              <a:buNone/>
               <a:defRPr sz="900" b="1">
                 <a:solidFill>
                   <a:srgbClr val="475569"/>
@@ -12137,7 +12139,7 @@
                 <a:ea typeface="微软雅黑"/>
                 <a:cs typeface="微软雅黑"/>
               </a:rPr>
-              <a:t>01 · 场景价值与复制性</a:t>
+              <a:t>01 · 真实实验室流程与价值</a:t>
             </a:r>
             <a:endParaRPr sz="1200"/>
           </a:p>
@@ -12183,7 +12185,7 @@
                 <a:ea typeface="微软雅黑"/>
                 <a:cs typeface="微软雅黑"/>
               </a:rPr>
-              <a:t>AI Engineering：首个验证场景</a:t>
+              <a:t>一次评测漂移，为什么会变成跨角色返工</a:t>
             </a:r>
             <a:endParaRPr sz="2900"/>
           </a:p>
@@ -12225,7 +12227,7 @@
                 <a:ea typeface="微软雅黑"/>
                 <a:cs typeface="微软雅黑"/>
               </a:rPr>
-              <a:t>验证场景不等于项目定义；Trust Contract 与执行治理链可迁移。</a:t>
+              <a:t>证据分散、责任交叉、重复运行；LabOps 把采证、审批、执行与审计固化为证据链。</a:t>
             </a:r>
             <a:endParaRPr>
               <a:latin typeface="微软雅黑"/>
@@ -12289,7 +12291,7 @@
                 <a:ea typeface="微软雅黑"/>
                 <a:cs typeface="微软雅黑"/>
               </a:rPr>
-              <a:t>验证场景</a:t>
+              <a:t>传统实验室</a:t>
             </a:r>
           </a:p>
         </p:txBody>
@@ -12348,7 +12350,7 @@
                 <a:ea typeface="微软雅黑"/>
                 <a:cs typeface="微软雅黑"/>
               </a:rPr>
-              <a:t>AI Engineering</a:t>
+              <a:t>多轮人工返工</a:t>
             </a:r>
           </a:p>
         </p:txBody>
@@ -12407,7 +12409,7 @@
                 <a:ea typeface="微软雅黑"/>
                 <a:cs typeface="微软雅黑"/>
               </a:rPr>
-              <a:t>事故触发、采证、分析、计划、受控执行与独立验证形成可复核闭环。</a:t>
+              <a:t>值班发现 → 工程师找证据 → 研究员分析 → 负责人审批 → 修改重跑 → 独立复核。</a:t>
             </a:r>
           </a:p>
         </p:txBody>
@@ -12466,7 +12468,7 @@
                 <a:ea typeface="微软雅黑"/>
                 <a:cs typeface="微软雅黑"/>
               </a:rPr>
-              <a:t>架构复用</a:t>
+              <a:t>LabOps 引入后</a:t>
             </a:r>
           </a:p>
         </p:txBody>
@@ -12525,7 +12527,7 @@
                 <a:ea typeface="微软雅黑"/>
                 <a:cs typeface="微软雅黑"/>
               </a:rPr>
-              <a:t>4 类 Agent</a:t>
+              <a:t>一次受控闭环</a:t>
             </a:r>
           </a:p>
         </p:txBody>
@@ -12584,7 +12586,7 @@
                 <a:ea typeface="微软雅黑"/>
                 <a:cs typeface="微软雅黑"/>
               </a:rPr>
-              <a:t>可迁移到 Coding、Data、Research、Deployment Agent；本版本不宣称已全部实现。</a:t>
+              <a:t>Incident → Evidence → RCA → Plan → Approval → Runner → Audit；每步有 owner 与证据引用。</a:t>
             </a:r>
           </a:p>
         </p:txBody>
@@ -12621,7 +12623,7 @@
         </p:spPr>
         <p:txBody>
           <a:bodyPr xmlns:a="http://schemas.openxmlformats.org/drawingml/2006/main" lIns="133350" tIns="76200" rIns="133350" bIns="76200" anchor="ctr">
-            <a:normAutofit fontScale="100000"/>
+            <a:normAutofit fontScale="99531"/>
           </a:bodyPr>
           <a:lstStyle xmlns:a="http://schemas.openxmlformats.org/drawingml/2006/main"/>
           <a:p xmlns:a="http://schemas.openxmlformats.org/drawingml/2006/main">
@@ -12645,7 +12647,7 @@
                 <a:ea typeface="微软雅黑"/>
                 <a:cs typeface="微软雅黑"/>
               </a:rPr>
-              <a:t>首个验证场景 ≠ 项目定义 · 可复用的是 Trust Contract 与执行治理链</a:t>
+              <a:t>受控指标：人工接触 · 消息往返 · 重复运行 · 证据完整度 · 错误关闭 · 处理时间</a:t>
             </a:r>
           </a:p>
         </p:txBody>
@@ -13431,7 +13433,7 @@
                 <a:ea typeface="微软雅黑"/>
                 <a:cs typeface="微软雅黑"/>
               </a:rPr>
-              <a:t>六 Agent 的价值是职责隔离，不是角色数量</a:t>
+              <a:t>任务分派、上下文、状态与责任全部可核验</a:t>
             </a:r>
             <a:endParaRPr sz="2900"/>
           </a:p>
@@ -13473,7 +13475,7 @@
                 <a:ea typeface="微软雅黑"/>
                 <a:cs typeface="微软雅黑"/>
               </a:rPr>
-              <a:t>六个 Identity 共享状态与证据；Executor 不能自证成功，Auditor 独占终态裁决。</a:t>
+              <a:t>handoff 绑定 task / incident / attempt、输入输出 artifact、状态、时间与 Matrix event ID。</a:t>
             </a:r>
             <a:endParaRPr>
               <a:latin typeface="微软雅黑"/>
@@ -14301,7 +14303,7 @@
                 <a:ea typeface="微软雅黑"/>
                 <a:cs typeface="微软雅黑"/>
               </a:rPr>
-              <a:t>真实 handoff 留痕</a:t>
+              <a:t>异常恢复</a:t>
             </a:r>
           </a:p>
           <a:p xmlns:a="http://schemas.openxmlformats.org/drawingml/2006/main">
@@ -14325,7 +14327,7 @@
                 <a:ea typeface="微软雅黑"/>
                 <a:cs typeface="微软雅黑"/>
               </a:rPr>
-              <a:t>Manager / Worker</a:t>
+              <a:t>BLOCKED → Retry / Reassign</a:t>
             </a:r>
           </a:p>
           <a:p xmlns:a="http://schemas.openxmlformats.org/drawingml/2006/main">
@@ -14349,7 +14351,7 @@
                 <a:ea typeface="微软雅黑"/>
                 <a:cs typeface="微软雅黑"/>
               </a:rPr>
-              <a:t>task + event reference</a:t>
+              <a:t>→ Takeover / new attempt</a:t>
             </a:r>
           </a:p>
         </p:txBody>
@@ -14414,7 +14416,7 @@
                 <a:ea typeface="微软雅黑"/>
                 <a:cs typeface="微软雅黑"/>
               </a:rPr>
-              <a:t>Separation of Duties</a:t>
+              <a:t>责任边界</a:t>
             </a:r>
           </a:p>
           <a:p xmlns:a="http://schemas.openxmlformats.org/drawingml/2006/main">
@@ -14438,7 +14440,7 @@
                 <a:ea typeface="微软雅黑"/>
                 <a:cs typeface="微软雅黑"/>
               </a:rPr>
-              <a:t>Executor ≠ Auditor</a:t>
+              <a:t>真人 Approval ≠ Human Takeover</a:t>
             </a:r>
           </a:p>
           <a:p xmlns:a="http://schemas.openxmlformats.org/drawingml/2006/main">
@@ -14462,7 +14464,7 @@
                 <a:ea typeface="微软雅黑"/>
                 <a:cs typeface="微软雅黑"/>
               </a:rPr>
-              <a:t>RESOLVED / ROLLED_BACK / BLOCKED</a:t>
+              <a:t>Auditor 独占终态裁决</a:t>
             </a:r>
           </a:p>
         </p:txBody>
@@ -14582,7 +14584,7 @@
                 <a:ea typeface="微软雅黑"/>
                 <a:cs typeface="微软雅黑"/>
               </a:rPr>
-              <a:t>7 个可复用、版本化、可验证的能力契约</a:t>
+              <a:t>7 个 Skill：工程契约完整，证据边界清晰</a:t>
             </a:r>
             <a:endParaRPr sz="2900"/>
           </a:p>
@@ -14699,7 +14701,7 @@
                 <a:ea typeface="微软雅黑"/>
                 <a:cs typeface="微软雅黑"/>
               </a:rPr>
-              <a:t>Skill 不是 Prompt：Registry 绑定 Owner、I/O、调用条件、失败状态、安全边界与验证方法。</a:t>
+              <a:t>7 个 Skill 声明 Owner、I/O、调用条件、工具权限、失败、安全、验证与复用。</a:t>
             </a:r>
             <a:endParaRPr>
               <a:latin typeface="微软雅黑"/>
@@ -15438,7 +15440,7 @@
         </p:spPr>
         <p:txBody>
           <a:bodyPr xmlns:a="http://schemas.openxmlformats.org/drawingml/2006/main" lIns="133350" tIns="76200" rIns="133350" bIns="76200" anchor="ctr">
-            <a:normAutofit fontScale="100000"/>
+            <a:normAutofit fontScale="98332"/>
           </a:bodyPr>
           <a:lstStyle xmlns:a="http://schemas.openxmlformats.org/drawingml/2006/main"/>
           <a:p xmlns:a="http://schemas.openxmlformats.org/drawingml/2006/main">
@@ -15462,7 +15464,7 @@
                 <a:ea typeface="微软雅黑"/>
                 <a:cs typeface="微软雅黑"/>
               </a:rPr>
-              <a:t>Registry · Version · Owner · I/O Schema · Invocation · Failure · Security · Validation · Reuse</a:t>
+              <a:t>Registry · Version · Owner · I/O · Invocation · Tool Permission · Failure · Security · Validation · Reuse</a:t>
             </a:r>
           </a:p>
         </p:txBody>
@@ -15527,7 +15529,7 @@
                 <a:ea typeface="微软雅黑"/>
                 <a:cs typeface="微软雅黑"/>
               </a:rPr>
-              <a:t>Commander Skills</a:t>
+              <a:t>Runtime evidence</a:t>
             </a:r>
           </a:p>
           <a:p xmlns:a="http://schemas.openxmlformats.org/drawingml/2006/main">
@@ -15551,7 +15553,7 @@
                 <a:ea typeface="微软雅黑"/>
                 <a:cs typeface="微软雅黑"/>
               </a:rPr>
-              <a:t>pack-lab-evidence 0.2.0  ·  publish-case-memory 0.1.0</a:t>
+              <a:t>control-lab-action: Gateway-verifiable  ·  other 6: hook required</a:t>
             </a:r>
           </a:p>
         </p:txBody>
@@ -15671,7 +15673,7 @@
                 <a:ea typeface="微软雅黑"/>
                 <a:cs typeface="微软雅黑"/>
               </a:rPr>
-              <a:t>Agent、Skill、Tool 三层分离</a:t>
+              <a:t>一个 Skill 的真实 Tool 绑定</a:t>
             </a:r>
             <a:endParaRPr sz="2900"/>
           </a:p>
@@ -15713,7 +15715,7 @@
                 <a:ea typeface="微软雅黑"/>
                 <a:cs typeface="微软雅黑"/>
               </a:rPr>
-              <a:t>control-lab-action v0.2.0 · owner=safe-executor · 真实可验证契约</a:t>
+              <a:t>新 live verifier 仅在归档契约与 Gateway / Runner 证据一致时确认。</a:t>
             </a:r>
             <a:endParaRPr>
               <a:latin typeface="微软雅黑"/>
@@ -16644,7 +16646,7 @@
                 <a:ea typeface="微软雅黑"/>
                 <a:cs typeface="微软雅黑"/>
               </a:rPr>
-              <a:t>Invocation：Policy passed &amp;&amp; scoped approval exists</a:t>
+              <a:t>safe-executor → control-lab-action → labops.runner.execute</a:t>
             </a:r>
           </a:p>
         </p:txBody>
@@ -16709,7 +16711,7 @@
                 <a:ea typeface="微软雅黑"/>
                 <a:cs typeface="微软雅黑"/>
               </a:rPr>
-              <a:t>Failure</a:t>
+              <a:t>Fail closed</a:t>
             </a:r>
           </a:p>
           <a:p xmlns:a="http://schemas.openxmlformats.org/drawingml/2006/main">
@@ -16733,7 +16735,7 @@
                 <a:ea typeface="微软雅黑"/>
                 <a:cs typeface="微软雅黑"/>
               </a:rPr>
-              <a:t>capability missing / timeout / policy mismatch</a:t>
+              <a:t>missing / reduced / forged contract</a:t>
             </a:r>
           </a:p>
           <a:p xmlns:a="http://schemas.openxmlformats.org/drawingml/2006/main">
@@ -16757,7 +16759,7 @@
                 <a:ea typeface="微软雅黑"/>
                 <a:cs typeface="微软雅黑"/>
               </a:rPr>
-              <a:t>→ fail closed</a:t>
+              <a:t>→ BLOCKED</a:t>
             </a:r>
           </a:p>
         </p:txBody>
@@ -16822,7 +16824,7 @@
                 <a:ea typeface="微软雅黑"/>
                 <a:cs typeface="微软雅黑"/>
               </a:rPr>
-              <a:t>Validation + Reuse</a:t>
+              <a:t>Evidence boundary</a:t>
             </a:r>
           </a:p>
           <a:p xmlns:a="http://schemas.openxmlformats.org/drawingml/2006/main">
@@ -16846,7 +16848,7 @@
                 <a:ea typeface="微软雅黑"/>
                 <a:cs typeface="微软雅黑"/>
               </a:rPr>
-              <a:t>manifest + protected hashes</a:t>
+              <a:t>1 Skill: Gateway-verifiable</a:t>
             </a:r>
           </a:p>
           <a:p xmlns:a="http://schemas.openxmlformats.org/drawingml/2006/main">
@@ -16870,7 +16872,7 @@
                 <a:ea typeface="微软雅黑"/>
                 <a:cs typeface="微软雅黑"/>
               </a:rPr>
-              <a:t>evaluation / data / controlled engineering</a:t>
+              <a:t>6 Skills: CONFIGURED / hook required</a:t>
             </a:r>
           </a:p>
         </p:txBody>
@@ -16990,7 +16992,7 @@
                 <a:ea typeface="微软雅黑"/>
                 <a:cs typeface="微软雅黑"/>
               </a:rPr>
-              <a:t>Agent 不能直接调用真实工程环境</a:t>
+              <a:t>真人批准必须与具体计划强绑定</a:t>
             </a:r>
             <a:endParaRPr sz="2900"/>
           </a:p>
@@ -17032,7 +17034,7 @@
                 <a:ea typeface="微软雅黑"/>
                 <a:cs typeface="微软雅黑"/>
               </a:rPr>
-              <a:t>Plan → Policy → Human Approval → Tool Contract → Gateway → 一次性断网 Runner</a:t>
+              <a:t>ApprovalGrant v1 绑定计划哈希、范围、副作用、保护对象、预算、时效、nonce 与 run。</a:t>
             </a:r>
             <a:endParaRPr>
               <a:latin typeface="微软雅黑"/>
@@ -17358,7 +17360,7 @@
                 <a:ea typeface="微软雅黑"/>
                 <a:cs typeface="微软雅黑"/>
               </a:rPr>
-              <a:t>Policy  →  Approval  →  Contract  →  Gateway allowlist</a:t>
+              <a:t>Plan hash → scope → protected resources → budget → expiry → nonce</a:t>
             </a:r>
           </a:p>
         </p:txBody>
@@ -17417,7 +17419,7 @@
                 <a:ea typeface="微软雅黑"/>
                 <a:cs typeface="微软雅黑"/>
               </a:rPr>
-              <a:t>tool_id · caller_agent_id · skill_id · run_id · approval_reference</a:t>
+              <a:t>incident_id · plan_id · canonical SHA-256 · run_id · approved_at</a:t>
             </a:r>
           </a:p>
         </p:txBody>
@@ -17482,7 +17484,7 @@
                 <a:ea typeface="微软雅黑"/>
                 <a:cs typeface="微软雅黑"/>
               </a:rPr>
-              <a:t>Tool Contract</a:t>
+              <a:t>ApprovalGrant v1</a:t>
             </a:r>
           </a:p>
           <a:p xmlns:a="http://schemas.openxmlformats.org/drawingml/2006/main">
@@ -17506,7 +17508,7 @@
                 <a:ea typeface="微软雅黑"/>
                 <a:cs typeface="微软雅黑"/>
               </a:rPr>
-              <a:t>身份 / 任务 / 审批</a:t>
+              <a:t>范围 / 副作用</a:t>
             </a:r>
           </a:p>
           <a:p xmlns:a="http://schemas.openxmlformats.org/drawingml/2006/main">
@@ -17530,7 +17532,7 @@
                 <a:ea typeface="微软雅黑"/>
                 <a:cs typeface="微软雅黑"/>
               </a:rPr>
-              <a:t>副作用 / 保护对象</a:t>
+              <a:t>保护对象 / 预算</a:t>
             </a:r>
           </a:p>
           <a:p xmlns:a="http://schemas.openxmlformats.org/drawingml/2006/main">
@@ -17554,7 +17556,7 @@
                 <a:ea typeface="微软雅黑"/>
                 <a:cs typeface="微软雅黑"/>
               </a:rPr>
-              <a:t>预算 / 幂等键</a:t>
+              <a:t>时效 / nonce</a:t>
             </a:r>
           </a:p>
         </p:txBody>
@@ -17952,7 +17954,7 @@
                 <a:ea typeface="微软雅黑"/>
                 <a:cs typeface="微软雅黑"/>
               </a:rPr>
-              <a:t>无审批或契约不一致 → Runner 不启动 / BLOCKED</a:t>
+              <a:t>任一绑定不一致或重放 → Runner 不启动</a:t>
             </a:r>
           </a:p>
         </p:txBody>

</xml_diff>

<commit_message>
docs: align semifinal candidate with official requirements
</commit_message>
<xml_diff>
--- a/submission/LabOps-Guard-GOAI-复赛方案-v1.0-rc1.pptx
+++ b/submission/LabOps-Guard-GOAI-复赛方案-v1.0-rc1.pptx
@@ -2,31 +2,31 @@
 <file path=ppt/presentation.xml><?xml version="1.0" encoding="utf-8"?>
 <p:presentation xmlns:p="http://schemas.openxmlformats.org/presentationml/2006/main">
   <p:sldMasterIdLst>
-    <p:sldMasterId xmlns:r="http://schemas.openxmlformats.org/officeDocument/2006/relationships" id="2147483648" r:id="R6aaefbe5bb1b4341"/>
-    <p:sldMasterId xmlns:r="http://schemas.openxmlformats.org/officeDocument/2006/relationships" id="2147483650" r:id="R830847ee9e404772"/>
+    <p:sldMasterId xmlns:r="http://schemas.openxmlformats.org/officeDocument/2006/relationships" id="2147483648" r:id="R984fbbd78c80469b"/>
+    <p:sldMasterId xmlns:r="http://schemas.openxmlformats.org/officeDocument/2006/relationships" id="2147483650" r:id="R70b028422ce049dd"/>
   </p:sldMasterIdLst>
   <p:notesMasterIdLst>
-    <p:notesMasterId xmlns:r="http://schemas.openxmlformats.org/officeDocument/2006/relationships" r:id="Rce7c93aeeabd4d78"/>
+    <p:notesMasterId xmlns:r="http://schemas.openxmlformats.org/officeDocument/2006/relationships" r:id="Rf14a0821b0ac48c0"/>
   </p:notesMasterIdLst>
   <p:sldIdLst>
-    <p:sldId xmlns:r="http://schemas.openxmlformats.org/officeDocument/2006/relationships" id="256" r:id="Rb42e70698db74d27"/>
-    <p:sldId xmlns:r="http://schemas.openxmlformats.org/officeDocument/2006/relationships" id="257" r:id="Rec87320b7d47492e"/>
-    <p:sldId xmlns:r="http://schemas.openxmlformats.org/officeDocument/2006/relationships" id="258" r:id="R09501167e352495d"/>
-    <p:sldId xmlns:r="http://schemas.openxmlformats.org/officeDocument/2006/relationships" id="259" r:id="Rbf46fd0bca074a96"/>
-    <p:sldId xmlns:r="http://schemas.openxmlformats.org/officeDocument/2006/relationships" id="260" r:id="Rb9f058ff619d45a3"/>
-    <p:sldId xmlns:r="http://schemas.openxmlformats.org/officeDocument/2006/relationships" id="261" r:id="R90304ee631d34a27"/>
-    <p:sldId xmlns:r="http://schemas.openxmlformats.org/officeDocument/2006/relationships" id="262" r:id="R6a1d08e935ad426b"/>
-    <p:sldId xmlns:r="http://schemas.openxmlformats.org/officeDocument/2006/relationships" id="263" r:id="R4cecb2347c3e41ae"/>
-    <p:sldId xmlns:r="http://schemas.openxmlformats.org/officeDocument/2006/relationships" id="264" r:id="Rb1a248d174904f61"/>
-    <p:sldId xmlns:r="http://schemas.openxmlformats.org/officeDocument/2006/relationships" id="265" r:id="R3b3fca69618444a7"/>
-    <p:sldId xmlns:r="http://schemas.openxmlformats.org/officeDocument/2006/relationships" id="266" r:id="R530dcbeb49134b14"/>
-    <p:sldId xmlns:r="http://schemas.openxmlformats.org/officeDocument/2006/relationships" id="267" r:id="R9cd20e558d054ce4"/>
-    <p:sldId xmlns:r="http://schemas.openxmlformats.org/officeDocument/2006/relationships" id="268" r:id="Rc2f796370e3f46dd"/>
-    <p:sldId xmlns:r="http://schemas.openxmlformats.org/officeDocument/2006/relationships" id="269" r:id="Rfa292f24c241426d"/>
-    <p:sldId xmlns:r="http://schemas.openxmlformats.org/officeDocument/2006/relationships" id="270" r:id="R8e063013d0c14448"/>
-    <p:sldId xmlns:r="http://schemas.openxmlformats.org/officeDocument/2006/relationships" id="271" r:id="R7bc3df798ae24f82"/>
-    <p:sldId xmlns:r="http://schemas.openxmlformats.org/officeDocument/2006/relationships" id="272" r:id="R506cb708fc534605"/>
-    <p:sldId xmlns:r="http://schemas.openxmlformats.org/officeDocument/2006/relationships" id="273" r:id="R794d114c70b24f51"/>
+    <p:sldId xmlns:r="http://schemas.openxmlformats.org/officeDocument/2006/relationships" id="256" r:id="R15cd43eec3414085"/>
+    <p:sldId xmlns:r="http://schemas.openxmlformats.org/officeDocument/2006/relationships" id="257" r:id="R494033fcc2ff47a6"/>
+    <p:sldId xmlns:r="http://schemas.openxmlformats.org/officeDocument/2006/relationships" id="258" r:id="R7aa64cf1e5e94215"/>
+    <p:sldId xmlns:r="http://schemas.openxmlformats.org/officeDocument/2006/relationships" id="259" r:id="R1fbeb763a7154106"/>
+    <p:sldId xmlns:r="http://schemas.openxmlformats.org/officeDocument/2006/relationships" id="260" r:id="Rc7df1c0efd1f4dc3"/>
+    <p:sldId xmlns:r="http://schemas.openxmlformats.org/officeDocument/2006/relationships" id="261" r:id="Re9af0b94472b417b"/>
+    <p:sldId xmlns:r="http://schemas.openxmlformats.org/officeDocument/2006/relationships" id="262" r:id="R438629570ca54ae5"/>
+    <p:sldId xmlns:r="http://schemas.openxmlformats.org/officeDocument/2006/relationships" id="263" r:id="R5d39490a3b3b4fd2"/>
+    <p:sldId xmlns:r="http://schemas.openxmlformats.org/officeDocument/2006/relationships" id="264" r:id="R8cf94c7ef3174a67"/>
+    <p:sldId xmlns:r="http://schemas.openxmlformats.org/officeDocument/2006/relationships" id="265" r:id="Rff525c14aede40c3"/>
+    <p:sldId xmlns:r="http://schemas.openxmlformats.org/officeDocument/2006/relationships" id="266" r:id="Re7451563f02445b9"/>
+    <p:sldId xmlns:r="http://schemas.openxmlformats.org/officeDocument/2006/relationships" id="267" r:id="R3aaf4ef7e1bf4e9c"/>
+    <p:sldId xmlns:r="http://schemas.openxmlformats.org/officeDocument/2006/relationships" id="268" r:id="Rcccedb4ad6c54214"/>
+    <p:sldId xmlns:r="http://schemas.openxmlformats.org/officeDocument/2006/relationships" id="269" r:id="Rde76f990d03c44c1"/>
+    <p:sldId xmlns:r="http://schemas.openxmlformats.org/officeDocument/2006/relationships" id="270" r:id="R03779b94db57450b"/>
+    <p:sldId xmlns:r="http://schemas.openxmlformats.org/officeDocument/2006/relationships" id="271" r:id="Ra9d7112e22a2411e"/>
+    <p:sldId xmlns:r="http://schemas.openxmlformats.org/officeDocument/2006/relationships" id="272" r:id="R855ef800246b482e"/>
+    <p:sldId xmlns:r="http://schemas.openxmlformats.org/officeDocument/2006/relationships" id="273" r:id="Rcd00fd1ab7014f07"/>
   </p:sldIdLst>
   <p:sldSz cx="12192000" cy="6858000"/>
   <p:notesSz cx="6858000" cy="9144000"/>
@@ -1087,6 +1087,14 @@
             </a:r>
             <a:endParaRPr/>
           </a:p>
+          <a:p xmlns:a="http://schemas.openxmlformats.org/drawingml/2006/main">
+            <a:r>
+              <a:t>
+[Sources]
+- GOAI 2026 Agent Infra 赛道官方说明，复赛章节 09–12（用户提供 PDF）
+- LabOps-Guard docs/observability.md</a:t>
+            </a:r>
+          </a:p>
         </p:txBody>
       </p:sp>
       <p:sp>
@@ -1182,6 +1190,15 @@
               <a:t>- docs/compliance/runner-license-review.md</a:t>
             </a:r>
           </a:p>
+          <a:p xmlns:a="http://schemas.openxmlformats.org/drawingml/2006/main">
+            <a:r>
+              <a:t>
+[Sources]
+- GOAI 2026 Agent Infra 赛道官方说明，复赛章节 09–12（用户提供 PDF）
+- LabOps-Guard docs/tool-and-context-equivalence.md
+- LabOps-Guard docs/toolchain-compatibility-matrix.md</a:t>
+            </a:r>
+          </a:p>
         </p:txBody>
       </p:sp>
       <p:sp>
@@ -1711,6 +1728,14 @@
               <a:t>- seven skills/*/SKILL.md</a:t>
             </a:r>
             <a:endParaRPr/>
+          </a:p>
+          <a:p xmlns:a="http://schemas.openxmlformats.org/drawingml/2006/main">
+            <a:r>
+              <a:t>
+[Sources]
+- GOAI 2026 Agent Infra 赛道官方说明，复赛章节 09–12（用户提供 PDF）
+- LabOps-Guard docs/skill-framework.md</a:t>
+            </a:r>
           </a:p>
         </p:txBody>
       </p:sp>
@@ -2065,7 +2090,7 @@
   </p:cSld>
   <p:clrMap bg1="lt1" tx1="dk1" bg2="lt2" tx2="dk2" accent1="accent1" accent2="accent2" accent3="accent3" accent4="accent4" accent5="accent5" accent6="accent6" hlink="hlink" folHlink="folHlink"/>
   <p:sldLayoutIdLst>
-    <p:sldLayoutId xmlns:r="http://schemas.openxmlformats.org/officeDocument/2006/relationships" id="2147483649" r:id="R34753fee4c7d4a2b"/>
+    <p:sldLayoutId xmlns:r="http://schemas.openxmlformats.org/officeDocument/2006/relationships" id="2147483649" r:id="Re90b552e4a84478c"/>
   </p:sldLayoutIdLst>
   <p:hf sldNum="0" hdr="0" ftr="0" dt="0"/>
   <p:txStyles>
@@ -2348,7 +2373,7 @@
   </p:cSld>
   <p:clrMap bg1="lt1" tx1="dk1" bg2="lt2" tx2="dk2" accent1="accent1" accent2="accent2" accent3="accent3" accent4="accent4" accent5="accent5" accent6="accent6" hlink="hlink" folHlink="folHlink"/>
   <p:sldLayoutIdLst>
-    <p:sldLayoutId xmlns:r="http://schemas.openxmlformats.org/officeDocument/2006/relationships" id="2147483651" r:id="R97aff0d3c34546e7"/>
+    <p:sldLayoutId xmlns:r="http://schemas.openxmlformats.org/officeDocument/2006/relationships" id="2147483651" r:id="R5c6d6cd3daea4fb6"/>
   </p:sldLayoutIdLst>
   <p:hf sldNum="0" hdr="0" ftr="0" dt="0"/>
   <p:txStyles>
@@ -4632,7 +4657,7 @@
           <p:nvPr/>
         </p:nvPicPr>
         <p:blipFill>
-          <a:blip xmlns:r="http://schemas.openxmlformats.org/officeDocument/2006/relationships" xmlns:a="http://schemas.openxmlformats.org/drawingml/2006/main" r:embed="R356634331864487a"/>
+          <a:blip xmlns:r="http://schemas.openxmlformats.org/officeDocument/2006/relationships" xmlns:a="http://schemas.openxmlformats.org/drawingml/2006/main" r:embed="Ra4eb4dd88d454eb8"/>
           <a:srcRect xmlns:a="http://schemas.openxmlformats.org/drawingml/2006/main" l="0" t="11709" r="0" b="11709"/>
           <a:stretch xmlns:a="http://schemas.openxmlformats.org/drawingml/2006/main">
             <a:fillRect l="0" t="0" r="0" b="0"/>
@@ -6679,7 +6704,7 @@
           <p:nvPr/>
         </p:nvPicPr>
         <p:blipFill>
-          <a:blip xmlns:r="http://schemas.openxmlformats.org/officeDocument/2006/relationships" xmlns:a="http://schemas.openxmlformats.org/drawingml/2006/main" r:embed="Rcd920ab25f8a4c1f"/>
+          <a:blip xmlns:r="http://schemas.openxmlformats.org/officeDocument/2006/relationships" xmlns:a="http://schemas.openxmlformats.org/drawingml/2006/main" r:embed="Rb0842852ee6248d1"/>
           <a:stretch xmlns:a="http://schemas.openxmlformats.org/drawingml/2006/main"/>
         </p:blipFill>
         <p:spPr>
@@ -9282,7 +9307,7 @@
                 <a:ea typeface="微软雅黑"/>
                 <a:cs typeface="微软雅黑"/>
               </a:rPr>
-              <a:t>append-only attempts · retry budget · real-worker proof · human accept/resume · Auditor final</a:t>
+              <a:t>structured failure signal · retry budget · reassign proof · escalation / takeover · Auditor final</a:t>
             </a:r>
           </a:p>
         </p:txBody>
@@ -9844,7 +9869,7 @@
                 <a:ea typeface="微软雅黑"/>
                 <a:cs typeface="微软雅黑"/>
               </a:rPr>
-              <a:t>策略身份、固定 allowlist 与文件型 observability；已支持 recovery / takeover，不宣称 HA 或多租户。</a:t>
+              <a:t>MCP 等价契约；无 RAG：Shared State + Trace；本地五信号，不宣称 OTel backend、HA 或多租户。</a:t>
             </a:r>
           </a:p>
         </p:txBody>
@@ -9881,7 +9906,7 @@
         </p:spPr>
         <p:txBody>
           <a:bodyPr xmlns:a="http://schemas.openxmlformats.org/drawingml/2006/main" lIns="133350" tIns="76200" rIns="133350" bIns="76200" anchor="ctr">
-            <a:normAutofit fontScale="73447"/>
+            <a:normAutofit fontScale="93958"/>
           </a:bodyPr>
           <a:lstStyle xmlns:a="http://schemas.openxmlformats.org/drawingml/2006/main"/>
           <a:p xmlns:a="http://schemas.openxmlformats.org/drawingml/2006/main">
@@ -9905,7 +9930,7 @@
                 <a:ea typeface="微软雅黑"/>
                 <a:cs typeface="微软雅黑"/>
               </a:rPr>
-              <a:t>路线：IAM/KMS · immutable storage · alerting · release rollback · OTel adapter · 本轮不堆叠组件</a:t>
+              <a:t>工具链：版本/权限/迁移已披露 · MCP/OTel 仅适配器路线 · 官方工具不按数量堆叠</a:t>
             </a:r>
           </a:p>
         </p:txBody>
@@ -10591,7 +10616,7 @@
           <p:nvPr/>
         </p:nvPicPr>
         <p:blipFill>
-          <a:blip xmlns:r="http://schemas.openxmlformats.org/officeDocument/2006/relationships" xmlns:a="http://schemas.openxmlformats.org/drawingml/2006/main" r:embed="R593df4d159a643cf"/>
+          <a:blip xmlns:r="http://schemas.openxmlformats.org/officeDocument/2006/relationships" xmlns:a="http://schemas.openxmlformats.org/drawingml/2006/main" r:embed="R98f3b124137b4fbf"/>
           <a:stretch xmlns:a="http://schemas.openxmlformats.org/drawingml/2006/main"/>
         </p:blipFill>
         <p:spPr>
@@ -10613,7 +10638,7 @@
           <p:nvPr/>
         </p:nvPicPr>
         <p:blipFill>
-          <a:blip xmlns:r="http://schemas.openxmlformats.org/officeDocument/2006/relationships" xmlns:a="http://schemas.openxmlformats.org/drawingml/2006/main" r:embed="R1aa701da4e6f494f"/>
+          <a:blip xmlns:r="http://schemas.openxmlformats.org/officeDocument/2006/relationships" xmlns:a="http://schemas.openxmlformats.org/drawingml/2006/main" r:embed="R7056a280c4b54fe3"/>
           <a:stretch xmlns:a="http://schemas.openxmlformats.org/drawingml/2006/main"/>
         </p:blipFill>
         <p:spPr>
@@ -15440,7 +15465,7 @@
         </p:spPr>
         <p:txBody>
           <a:bodyPr xmlns:a="http://schemas.openxmlformats.org/drawingml/2006/main" lIns="133350" tIns="76200" rIns="133350" bIns="76200" anchor="ctr">
-            <a:normAutofit fontScale="98332"/>
+            <a:normAutofit fontScale="96344"/>
           </a:bodyPr>
           <a:lstStyle xmlns:a="http://schemas.openxmlformats.org/drawingml/2006/main"/>
           <a:p xmlns:a="http://schemas.openxmlformats.org/drawingml/2006/main">
@@ -15464,7 +15489,7 @@
                 <a:ea typeface="微软雅黑"/>
                 <a:cs typeface="微软雅黑"/>
               </a:rPr>
-              <a:t>Registry · Version · Owner · I/O · Invocation · Tool Permission · Failure · Security · Validation · Reuse</a:t>
+              <a:t>Registry · Version · Owner · I/O · Invocation · Tool · Failure · Security · Release · Rollback · Quality Eval</a:t>
             </a:r>
           </a:p>
         </p:txBody>

</xml_diff>